<commit_message>
Remove dates from the README, infra guide and presentation
</commit_message>
<xml_diff>
--- a/docs/presentation/TrackFlow-Final-Demo.pptx
+++ b/docs/presentation/TrackFlow-Final-Demo.pptx
@@ -128,14 +128,14 @@
   <p:extLst>
     <p:ext uri="{521415D9-36F7-43E2-AB2F-B90AF26B5E84}">
       <p14:sectionLst xmlns:p14="http://schemas.microsoft.com/office/powerpoint/2010/main">
-        <p14:section name="Introduction" id="{b61050aa-c08d-8c7f-2ace-013981ba4fae}">
+        <p14:section name="Introduction" id="{5ae40164-c7b7-f79b-3923-e201f7da322f}">
           <p14:sldIdLst>
             <p14:sldId id="256"/>
             <p14:sldId id="257"/>
             <p14:sldId id="258"/>
           </p14:sldIdLst>
         </p14:section>
-        <p14:section name="The application" id="{6daeab18-7e40-3273-a860-7a2c3b1772cf}">
+        <p14:section name="The application" id="{c3599716-dbee-d08f-7efb-2e7254c9c8c7}">
           <p14:sldIdLst>
             <p14:sldId id="259"/>
             <p14:sldId id="260"/>
@@ -144,7 +144,7 @@
             <p14:sldId id="263"/>
           </p14:sldIdLst>
         </p14:section>
-        <p14:section name="Architecture" id="{a9c5791a-01ca-d03b-9d70-01a208ff80af}">
+        <p14:section name="Architecture" id="{0397da7a-29d5-0176-52f9-e14684be4b67}">
           <p14:sldIdLst>
             <p14:sldId id="264"/>
             <p14:sldId id="265"/>
@@ -154,14 +154,14 @@
             <p14:sldId id="269"/>
           </p14:sldIdLst>
         </p14:section>
-        <p14:section name="Deployment Portal" id="{c14077bf-a7cf-f9e8-b8bc-2f425601880e}">
+        <p14:section name="Deployment Portal" id="{86d51119-ed8b-6df5-8290-58efc584360f}">
           <p14:sldIdLst>
             <p14:sldId id="270"/>
             <p14:sldId id="271"/>
             <p14:sldId id="272"/>
           </p14:sldIdLst>
         </p14:section>
-        <p14:section name="Decisions" id="{68384742-3aa2-d72d-a01e-422a24b8d672}">
+        <p14:section name="Decisions" id="{6f347b46-2934-a056-5189-ba197f610217}">
           <p14:sldIdLst>
             <p14:sldId id="273"/>
             <p14:sldId id="274"/>
@@ -169,7 +169,7 @@
             <p14:sldId id="276"/>
           </p14:sldIdLst>
         </p14:section>
-        <p14:section name="Close" id="{08d33eb8-ed37-d1af-e3fb-d39c560f9414}">
+        <p14:section name="Close" id="{81bc1b9e-3a01-ac63-70c7-d5ceda731842}">
           <p14:sldIdLst>
             <p14:sldId id="277"/>
           </p14:sldIdLst>
@@ -1310,7 +1310,7 @@
           <a:p>
             <a:r>
               <a:rPr lang="en-US" dirty="0"/>
-              <a:t>Both failover tests were run live on 10 October by stopping the backend in a region. Losing us-east-1 moved traffic to us-west-2 in 38 seconds. Losing both AWS regions moved it to Azure in 45 seconds, and logins worked there. The target was two minutes.</a:t>
+              <a:t>Both failover tests were run live by stopping the backend in a region. Losing us-east-1 moved traffic to us-west-2 in 38 seconds. Losing both AWS regions moved it to Azure in 45 seconds, and logins worked there. The target was two minutes.</a:t>
             </a:r>
             <a:endParaRPr lang="en-US" dirty="0"/>
           </a:p>
@@ -1574,7 +1574,7 @@
           <a:p>
             <a:r>
               <a:rPr lang="en-US" dirty="0"/>
-              <a:t>We tested all three actions against the real cloud the day before the demo. An apply produces a working copy of the app with its own database and URL in about three minutes. QA and Prod run a real tofu plan, which is free. Destroy cleans everything up. The first apply also showed that failures are reported clearly: a hostname bug made the final check fail, the portal showed exactly which step failed and linked to the log, and we fixed it the same evening.</a:t>
+              <a:t>We tested all three actions against the real cloud. An apply produces a working copy of the app with its own database and URL in about three minutes. QA and Prod run a real tofu plan, which is free. Destroy cleans everything up. The first apply also showed that failures are reported clearly: a hostname bug made the final check fail, the portal showed exactly which step failed and linked to the log, and the fix was verified by the next deployment.</a:t>
             </a:r>
             <a:endParaRPr lang="en-US" dirty="0"/>
           </a:p>
@@ -1926,7 +1926,7 @@
           <a:p>
             <a:r>
               <a:rPr lang="en-US" dirty="0"/>
-              <a:t>Quality: 98 backend tests including integration tests against a real MySQL, 93 percent line coverage, and CI on every push. Cost: the full system costs about 1.45 dollars an hour from free credits, most of it the two EKS control planes: Kubernetes 1.33 moved to EKS extended support in July, which costs six times the standard price, and moving to 1.34 brings it back down. A scheduled workflow destroys everything every night unless we explicitly keep it up.</a:t>
+              <a:t>Quality: 98 backend tests including integration tests against a real MySQL, 93 percent line coverage, and CI on every push. Cost: the full system costs about 1.45 dollars an hour from free credits, most of it the two EKS control planes: Kubernetes 1.33 is in EKS extended support, which costs six times the standard price, and moving to 1.34 brings it back down. A scheduled workflow destroys everything every night unless we explicitly keep it up.</a:t>
             </a:r>
             <a:endParaRPr lang="en-US" dirty="0"/>
           </a:p>
@@ -3672,42 +3672,6 @@
         </p:nvSpPr>
         <p:spPr>
           <a:xfrm>
-            <a:off x="731520" y="4800600"/>
-            <a:ext cx="5486400" cy="365760"/>
-          </a:xfrm>
-          <a:prstGeom prst="rect">
-            <a:avLst/>
-          </a:prstGeom>
-          <a:noFill/>
-          <a:ln/>
-        </p:spPr>
-        <p:txBody>
-          <a:bodyPr wrap="square" lIns="0" tIns="0" rIns="0" bIns="0" rtlCol="0" anchor="t"/>
-          <a:lstStyle/>
-          <a:p>
-            <a:pPr indent="0" marL="0">
-              <a:buNone/>
-            </a:pPr>
-            <a:r>
-              <a:rPr lang="en-US" sz="1600" b="1" dirty="0">
-                <a:solidFill>
-                  <a:schemeClr val="accent2"/>
-                </a:solidFill>
-              </a:rPr>
-              <a:t>Final demo · 14 October 2026</a:t>
-            </a:r>
-            <a:endParaRPr lang="en-US" sz="1600" dirty="0"/>
-          </a:p>
-        </p:txBody>
-      </p:sp>
-      <p:sp>
-        <p:nvSpPr>
-          <p:cNvPr id="5" name="Text 3"/>
-          <p:cNvSpPr txBox="1"/>
-          <p:nvPr/>
-        </p:nvSpPr>
-        <p:spPr>
-          <a:xfrm>
             <a:off x="731520" y="5212080"/>
             <a:ext cx="8229600" cy="365760"/>
           </a:xfrm>
@@ -3738,7 +3702,7 @@
       </p:sp>
       <p:sp>
         <p:nvSpPr>
-          <p:cNvPr id="6" name="Shape 4"/>
+          <p:cNvPr id="5" name="Shape 3"/>
           <p:cNvSpPr/>
           <p:nvPr/>
         </p:nvSpPr>
@@ -3758,7 +3722,7 @@
       </p:sp>
       <p:pic>
         <p:nvPicPr>
-          <p:cNvPr id="7" name="Image 0" descr="preencoded.png">    </p:cNvPr>
+          <p:cNvPr id="6" name="Image 0" descr="preencoded.png">    </p:cNvPr>
           <p:cNvPicPr>
             <a:picLocks noChangeAspect="1"/>
           </p:cNvPicPr>
@@ -3782,7 +3746,7 @@
       </p:pic>
       <p:sp>
         <p:nvSpPr>
-          <p:cNvPr id="8" name="Shape 5"/>
+          <p:cNvPr id="7" name="Shape 4"/>
           <p:cNvSpPr/>
           <p:nvPr/>
         </p:nvSpPr>
@@ -3802,7 +3766,7 @@
       </p:sp>
       <p:pic>
         <p:nvPicPr>
-          <p:cNvPr id="9" name="Image 1" descr="preencoded.png">    </p:cNvPr>
+          <p:cNvPr id="8" name="Image 1" descr="preencoded.png">    </p:cNvPr>
           <p:cNvPicPr>
             <a:picLocks noChangeAspect="1"/>
           </p:cNvPicPr>
@@ -3826,7 +3790,7 @@
       </p:pic>
       <p:sp>
         <p:nvSpPr>
-          <p:cNvPr id="10" name="Shape 6"/>
+          <p:cNvPr id="9" name="Shape 5"/>
           <p:cNvSpPr/>
           <p:nvPr/>
         </p:nvSpPr>
@@ -3846,7 +3810,7 @@
       </p:sp>
       <p:pic>
         <p:nvPicPr>
-          <p:cNvPr id="11" name="Image 2" descr="preencoded.png">    </p:cNvPr>
+          <p:cNvPr id="10" name="Image 2" descr="preencoded.png">    </p:cNvPr>
           <p:cNvPicPr>
             <a:picLocks noChangeAspect="1"/>
           </p:cNvPicPr>
@@ -10637,7 +10601,7 @@
                   <a:schemeClr val="tx1"/>
                 </a:solidFill>
               </a:rPr>
-              <a:t>Three actions, all tested live on 13 October</a:t>
+              <a:t>Three actions, all tested live</a:t>
             </a:r>
             <a:endParaRPr lang="en-US" sz="3200" dirty="0"/>
           </a:p>

</xml_diff>